<commit_message>
Căn cứ xếp theo đối tượng giáo viên: văn bản Bộ GDĐT 2026 đứng đầu
- Thông tư 18/2026/TT-BGDĐT, CV 5385/BGDĐT-GDMN, CV 5208/BGDĐT-GDPT, QĐ 2422/QĐ-BGDĐT, CV 5588/BGDĐT-GDPT, Chỉ thị 31/CT-TTg
- Bài 34 viết lại theo Khung năng lực số của giáo viên
- Bỏ mã cũ trong chú thích hình, 197 tham chiếu trang kiểm tra lại
- Ảnh bán 1 và 2 cập nhật theo văn bản Bộ GDĐT 2026

Co-Authored-By: Claude Opus 5.5 <noreply@anthropic.com>
Claude-Session: https://claude.ai/code/session_016W4H5FXW9gSiS33Aau8aSB
</commit_message>
<xml_diff>
--- a/BO-TAI-LIEU-GUI-KHACH/04-Slide-tap-huan.pptx
+++ b/BO-TAI-LIEU-GUI-KHACH/04-Slide-tap-huan.pptx
@@ -613,7 +613,7 @@
           <a:p>
             <a:r>
               <a:rPr lang="en-US" dirty="0"/>
-              <a:t>TPACK: điền đủ 3 dòng CK, PK, TK. Học viên mở tệp 01, Bài 10, trang 24.</a:t>
+              <a:t>TPACK: điền đủ 3 dòng CK, PK, TK. Học viên mở tệp 01, Bài 10, trang 25.</a:t>
             </a:r>
             <a:endParaRPr lang="en-US" dirty="0"/>
           </a:p>
@@ -789,7 +789,7 @@
           <a:p>
             <a:r>
               <a:rPr lang="en-US" dirty="0"/>
-              <a:t>Câu lệnh dài chia 4 ngăn có tiêu đề #. Học viên mở tệp 01, Bài 15, trang 31.</a:t>
+              <a:t>Câu lệnh dài chia 4 ngăn có tiêu đề #. Học viên mở tệp 01, Bài 15, trang 32.</a:t>
             </a:r>
             <a:endParaRPr lang="en-US" dirty="0"/>
           </a:p>
@@ -877,7 +877,7 @@
           <a:p>
             <a:r>
               <a:rPr lang="en-US" dirty="0"/>
-              <a:t>Dán nguyên văn định nghĩa 4 mức độ nhận thức vào câu lệnh. Học viên mở tệp 01, Bài 16, trang 33.</a:t>
+              <a:t>Dán nguyên văn định nghĩa 4 mức độ nhận thức vào câu lệnh. Học viên mở tệp 01, Bài 16, trang 34.</a:t>
             </a:r>
             <a:endParaRPr lang="en-US" dirty="0"/>
           </a:p>
@@ -965,7 +965,7 @@
           <a:p>
             <a:r>
               <a:rPr lang="en-US" dirty="0"/>
-              <a:t>AI kẻ bảng tiêu chí 4 mức, giáo viên duyệt. Học viên mở tệp 01, Bài 17, trang 35.</a:t>
+              <a:t>AI kẻ bảng tiêu chí 4 mức, giáo viên duyệt. Học viên mở tệp 01, Bài 17, trang 36.</a:t>
             </a:r>
             <a:endParaRPr lang="en-US" dirty="0"/>
           </a:p>
@@ -1141,7 +1141,7 @@
           <a:p>
             <a:r>
               <a:rPr lang="en-US" dirty="0"/>
-              <a:t>Chọn công cụ theo sản phẩm muốn làm. Học viên mở tệp 01, Phần 4, trang 39.</a:t>
+              <a:t>Chọn công cụ theo sản phẩm muốn làm. Học viên mở tệp 01, Phần 4, trang 40.</a:t>
             </a:r>
             <a:endParaRPr lang="en-US" dirty="0"/>
           </a:p>
@@ -1229,7 +1229,7 @@
           <a:p>
             <a:r>
               <a:rPr lang="en-US" dirty="0"/>
-              <a:t>Câu lệnh tạo ảnh: Nội dung + Phong cách. Học viên mở tệp 01, Bài 20, trang 40.</a:t>
+              <a:t>Câu lệnh tạo ảnh: Nội dung + Phong cách. Học viên mở tệp 01, Bài 20, trang 41.</a:t>
             </a:r>
             <a:endParaRPr lang="en-US" dirty="0"/>
           </a:p>
@@ -1405,7 +1405,7 @@
           <a:p>
             <a:r>
               <a:rPr lang="en-US" dirty="0"/>
-              <a:t>Deep Research: giao đề bài, duyệt kế hoạch, chờ báo cáo, tự mở từng link để kiểm. Học viên mở tệp 01, Bài 28, trang 55.</a:t>
+              <a:t>Deep Research: giao đề bài, duyệt kế hoạch, chờ báo cáo, tự mở từng link để kiểm. Học viên mở tệp 01, Bài 28, trang 56.</a:t>
             </a:r>
             <a:endParaRPr lang="en-US" dirty="0"/>
           </a:p>
@@ -1581,7 +1581,7 @@
           <a:p>
             <a:r>
               <a:rPr lang="en-US" dirty="0"/>
-              <a:t>Tạo trợ giảng ảo 4 bước. Câu quan trọng nhất: không đưa ra ngay đáp án. Học viên mở tệp 01, Bài 31, trang 59.</a:t>
+              <a:t>Tạo trợ giảng ảo 4 bước. Câu quan trọng nhất: không đưa ra ngay đáp án. Học viên mở tệp 01, Bài 31, trang 60.</a:t>
             </a:r>
             <a:endParaRPr lang="en-US" dirty="0"/>
           </a:p>
@@ -1669,7 +1669,7 @@
           <a:p>
             <a:r>
               <a:rPr lang="en-US" dirty="0"/>
-              <a:t>Khung năng lực AI cho giáo viên của UNESCO: 5 lĩnh vực, 3 cấp độ. Học viên mở tệp 01, Bài 34, trang 66.</a:t>
+              <a:t>Khung năng lực AI cho giáo viên của UNESCO: 5 lĩnh vực, 3 cấp độ. Học viên mở tệp 01, Bài 34, trang 67.</a:t>
             </a:r>
             <a:endParaRPr lang="en-US" dirty="0"/>
           </a:p>
@@ -1757,7 +1757,7 @@
           <a:p>
             <a:r>
               <a:rPr lang="en-US" dirty="0"/>
-              <a:t>Ba màu đèn trước khi dán thông tin vào AI. Học viên mở tệp 01, Bài 35, trang 67.</a:t>
+              <a:t>Ba màu đèn trước khi dán thông tin vào AI. Học viên mở tệp 01, Bài 35, trang 69.</a:t>
             </a:r>
             <a:endParaRPr lang="en-US" dirty="0"/>
           </a:p>
@@ -1845,7 +1845,7 @@
           <a:p>
             <a:r>
               <a:rPr lang="en-US" dirty="0"/>
-              <a:t>Gợi ý bắt đầu theo cấp học. Học viên mở tệp 01, Phụ lục 1, trang 70.</a:t>
+              <a:t>Gợi ý bắt đầu theo cấp học. Học viên mở tệp 01, Phụ lục 1, trang 72.</a:t>
             </a:r>
             <a:endParaRPr lang="en-US" dirty="0"/>
           </a:p>
@@ -2109,7 +2109,7 @@
           <a:p>
             <a:r>
               <a:rPr lang="en-US" dirty="0"/>
-              <a:t>Vòng làm việc Hỏi, Đọc, Sửa, Kiểm. Nhấn mạnh bước Kiểm. Học viên mở tệp 01, Bài 1, trang 9.</a:t>
+              <a:t>Vòng làm việc Hỏi, Đọc, Sửa, Kiểm. Nhấn mạnh bước Kiểm. Học viên mở tệp 01, Bài 1, trang 10.</a:t>
             </a:r>
             <a:endParaRPr lang="en-US" dirty="0"/>
           </a:p>
@@ -2197,7 +2197,7 @@
           <a:p>
             <a:r>
               <a:rPr lang="en-US" dirty="0"/>
-              <a:t>Sáu vị trí trên màn hình trò chuyện với AI. Cho học viên mở chatgpt.com và tìm đủ 6 vị trí. Học viên mở tệp 01, Bài 2, trang 10.</a:t>
+              <a:t>Sáu vị trí trên màn hình trò chuyện với AI. Cho học viên mở chatgpt.com và tìm đủ 6 vị trí. Học viên mở tệp 01, Bài 2, trang 11.</a:t>
             </a:r>
             <a:endParaRPr lang="en-US" dirty="0"/>
           </a:p>
@@ -2285,7 +2285,7 @@
           <a:p>
             <a:r>
               <a:rPr lang="en-US" dirty="0"/>
-              <a:t>Sáu mảnh ghép của câu lệnh tốt. Học viên mở tệp 01, Bài 3, trang 12.</a:t>
+              <a:t>Sáu mảnh ghép của câu lệnh tốt. Học viên mở tệp 01, Bài 3, trang 13.</a:t>
             </a:r>
             <a:endParaRPr lang="en-US" dirty="0"/>
           </a:p>
@@ -2461,7 +2461,7 @@
           <a:p>
             <a:r>
               <a:rPr lang="en-US" dirty="0"/>
-              <a:t>Bốn cách hỏi từ dễ đến đủ. Học viên thử lần lượt 4 câu lệnh trên cùng một bài dạy. Học viên mở tệp 01, Bài 4 (trang 15) đến Bài 7 (trang 19).</a:t>
+              <a:t>Bốn cách hỏi từ dễ đến đủ. Học viên thử lần lượt 4 câu lệnh trên cùng một bài dạy. Học viên mở tệp 01, Bài 4 (trang 16) đến Bài 7 (trang 20).</a:t>
             </a:r>
             <a:endParaRPr lang="en-US" dirty="0"/>
           </a:p>
@@ -2549,7 +2549,7 @@
           <a:p>
             <a:r>
               <a:rPr lang="en-US" dirty="0"/>
-              <a:t>Tự chấm câu lệnh theo 6 mảnh ghép, thiếu gì thêm nấy. Học viên mở tệp 01, Bài 8, trang 21.</a:t>
+              <a:t>Tự chấm câu lệnh theo 6 mảnh ghép, thiếu gì thêm nấy. Học viên mở tệp 01, Bài 8, trang 22.</a:t>
             </a:r>
             <a:endParaRPr lang="en-US" dirty="0"/>
           </a:p>
@@ -3260,7 +3260,7 @@
                 <a:ea typeface="Arial" pitchFamily="34" charset="-122"/>
                 <a:cs typeface="Arial" pitchFamily="34" charset="-120"/>
               </a:rPr>
-              <a:t>Đọc kỹ trong sách: Bài 10, trang 24</a:t>
+              <a:t>Đọc kỹ trong sách: Bài 10, trang 25</a:t>
             </a:r>
             <a:endParaRPr lang="en-US" sz="1000" dirty="0"/>
           </a:p>
@@ -3507,7 +3507,7 @@
                 <a:ea typeface="Arial" pitchFamily="34" charset="-122"/>
                 <a:cs typeface="Arial" pitchFamily="34" charset="-120"/>
               </a:rPr>
-              <a:t>Bài 11 đến Bài 19 · sách trang 27 đến 38</a:t>
+              <a:t>Bài 11 đến Bài 19 · sách trang 28 đến 39</a:t>
             </a:r>
             <a:endParaRPr lang="en-US" sz="1400" dirty="0"/>
           </a:p>
@@ -3629,7 +3629,7 @@
                 <a:ea typeface="Arial" pitchFamily="34" charset="-122"/>
                 <a:cs typeface="Arial" pitchFamily="34" charset="-120"/>
               </a:rPr>
-              <a:t>Đọc kỹ trong sách: Bài 15, trang 31</a:t>
+              <a:t>Đọc kỹ trong sách: Bài 15, trang 32</a:t>
             </a:r>
             <a:endParaRPr lang="en-US" sz="1000" dirty="0"/>
           </a:p>
@@ -3751,7 +3751,7 @@
                 <a:ea typeface="Arial" pitchFamily="34" charset="-122"/>
                 <a:cs typeface="Arial" pitchFamily="34" charset="-120"/>
               </a:rPr>
-              <a:t>Đọc kỹ trong sách: Bài 16, trang 33</a:t>
+              <a:t>Đọc kỹ trong sách: Bài 16, trang 34</a:t>
             </a:r>
             <a:endParaRPr lang="en-US" sz="1000" dirty="0"/>
           </a:p>
@@ -3873,7 +3873,7 @@
                 <a:ea typeface="Arial" pitchFamily="34" charset="-122"/>
                 <a:cs typeface="Arial" pitchFamily="34" charset="-120"/>
               </a:rPr>
-              <a:t>Đọc kỹ trong sách: Bài 17, trang 35</a:t>
+              <a:t>Đọc kỹ trong sách: Bài 17, trang 36</a:t>
             </a:r>
             <a:endParaRPr lang="en-US" sz="1000" dirty="0"/>
           </a:p>
@@ -4120,7 +4120,7 @@
                 <a:ea typeface="Arial" pitchFamily="34" charset="-122"/>
                 <a:cs typeface="Arial" pitchFamily="34" charset="-120"/>
               </a:rPr>
-              <a:t>Bài 20 đến Bài 27 · sách trang 40 đến 53</a:t>
+              <a:t>Bài 20 đến Bài 27 · sách trang 41 đến 54</a:t>
             </a:r>
             <a:endParaRPr lang="en-US" sz="1400" dirty="0"/>
           </a:p>
@@ -4242,7 +4242,7 @@
                 <a:ea typeface="Arial" pitchFamily="34" charset="-122"/>
                 <a:cs typeface="Arial" pitchFamily="34" charset="-120"/>
               </a:rPr>
-              <a:t>Đọc kỹ trong sách: Phần 4, trang 39</a:t>
+              <a:t>Đọc kỹ trong sách: Phần 4, trang 40</a:t>
             </a:r>
             <a:endParaRPr lang="en-US" sz="1000" dirty="0"/>
           </a:p>
@@ -4364,7 +4364,7 @@
                 <a:ea typeface="Arial" pitchFamily="34" charset="-122"/>
                 <a:cs typeface="Arial" pitchFamily="34" charset="-120"/>
               </a:rPr>
-              <a:t>Đọc kỹ trong sách: Bài 20, trang 40</a:t>
+              <a:t>Đọc kỹ trong sách: Bài 20, trang 41</a:t>
             </a:r>
             <a:endParaRPr lang="en-US" sz="1000" dirty="0"/>
           </a:p>
@@ -4611,7 +4611,7 @@
                 <a:ea typeface="Arial" pitchFamily="34" charset="-122"/>
                 <a:cs typeface="Arial" pitchFamily="34" charset="-120"/>
               </a:rPr>
-              <a:t>Bài 28 đến Bài 36 · sách trang 55 đến 68</a:t>
+              <a:t>Bài 28 đến Bài 36 · sách trang 56 đến 70</a:t>
             </a:r>
             <a:endParaRPr lang="en-US" sz="1400" dirty="0"/>
           </a:p>
@@ -4733,7 +4733,7 @@
                 <a:ea typeface="Arial" pitchFamily="34" charset="-122"/>
                 <a:cs typeface="Arial" pitchFamily="34" charset="-120"/>
               </a:rPr>
-              <a:t>Đọc kỹ trong sách: Bài 28, trang 55</a:t>
+              <a:t>Đọc kỹ trong sách: Bài 28, trang 56</a:t>
             </a:r>
             <a:endParaRPr lang="en-US" sz="1000" dirty="0"/>
           </a:p>
@@ -5007,7 +5007,7 @@
                 <a:ea typeface="Arial" pitchFamily="34" charset="-122"/>
                 <a:cs typeface="Arial" pitchFamily="34" charset="-120"/>
               </a:rPr>
-              <a:t>Sách: Phần 3, trang 26</a:t>
+              <a:t>Sách: Phần 3, trang 27</a:t>
             </a:r>
             <a:endParaRPr lang="en-US" sz="1000" dirty="0"/>
           </a:p>
@@ -5210,7 +5210,7 @@
                 <a:ea typeface="Arial" pitchFamily="34" charset="-122"/>
                 <a:cs typeface="Arial" pitchFamily="34" charset="-120"/>
               </a:rPr>
-              <a:t>Sách: Phần 3, trang 26</a:t>
+              <a:t>Sách: Phần 3, trang 27</a:t>
             </a:r>
             <a:endParaRPr lang="en-US" sz="1000" dirty="0"/>
           </a:p>
@@ -5413,7 +5413,7 @@
                 <a:ea typeface="Arial" pitchFamily="34" charset="-122"/>
                 <a:cs typeface="Arial" pitchFamily="34" charset="-120"/>
               </a:rPr>
-              <a:t>Sách: Phần 4, trang 39</a:t>
+              <a:t>Sách: Phần 4, trang 40</a:t>
             </a:r>
             <a:endParaRPr lang="en-US" sz="1000" dirty="0"/>
           </a:p>
@@ -5616,7 +5616,7 @@
                 <a:ea typeface="Arial" pitchFamily="34" charset="-122"/>
                 <a:cs typeface="Arial" pitchFamily="34" charset="-120"/>
               </a:rPr>
-              <a:t>Sách: Phần 5, trang 54</a:t>
+              <a:t>Sách: Phần 5, trang 55</a:t>
             </a:r>
             <a:endParaRPr lang="en-US" sz="1000" dirty="0"/>
           </a:p>
@@ -5738,7 +5738,7 @@
                 <a:ea typeface="Arial" pitchFamily="34" charset="-122"/>
                 <a:cs typeface="Arial" pitchFamily="34" charset="-120"/>
               </a:rPr>
-              <a:t>Đọc kỹ trong sách: Bài 31, trang 59</a:t>
+              <a:t>Đọc kỹ trong sách: Bài 31, trang 60</a:t>
             </a:r>
             <a:endParaRPr lang="en-US" sz="1000" dirty="0"/>
           </a:p>
@@ -5860,7 +5860,7 @@
                 <a:ea typeface="Arial" pitchFamily="34" charset="-122"/>
                 <a:cs typeface="Arial" pitchFamily="34" charset="-120"/>
               </a:rPr>
-              <a:t>Đọc kỹ trong sách: Bài 34, trang 66</a:t>
+              <a:t>Đọc kỹ trong sách: Bài 34, trang 67</a:t>
             </a:r>
             <a:endParaRPr lang="en-US" sz="1000" dirty="0"/>
           </a:p>
@@ -5982,7 +5982,7 @@
                 <a:ea typeface="Arial" pitchFamily="34" charset="-122"/>
                 <a:cs typeface="Arial" pitchFamily="34" charset="-120"/>
               </a:rPr>
-              <a:t>Đọc kỹ trong sách: Bài 35, trang 67</a:t>
+              <a:t>Đọc kỹ trong sách: Bài 35, trang 69</a:t>
             </a:r>
             <a:endParaRPr lang="en-US" sz="1000" dirty="0"/>
           </a:p>
@@ -6104,7 +6104,7 @@
                 <a:ea typeface="Arial" pitchFamily="34" charset="-122"/>
                 <a:cs typeface="Arial" pitchFamily="34" charset="-120"/>
               </a:rPr>
-              <a:t>Đọc kỹ trong sách: Phụ lục 1, trang 70</a:t>
+              <a:t>Đọc kỹ trong sách: Phụ lục 1, trang 72</a:t>
             </a:r>
             <a:endParaRPr lang="en-US" sz="1000" dirty="0"/>
           </a:p>
@@ -6280,7 +6280,7 @@
                 <a:ea typeface="Arial" pitchFamily="34" charset="-122"/>
                 <a:cs typeface="Arial" pitchFamily="34" charset="-120"/>
               </a:rPr>
-              <a:t>Làm theo sách: Bài 2, trang 10</a:t>
+              <a:t>Làm theo sách: Bài 2, trang 11</a:t>
             </a:r>
             <a:endParaRPr lang="en-US" sz="1500" dirty="0"/>
           </a:p>
@@ -6468,7 +6468,7 @@
                 <a:ea typeface="Arial" pitchFamily="34" charset="-122"/>
                 <a:cs typeface="Arial" pitchFamily="34" charset="-120"/>
               </a:rPr>
-              <a:t>Dựa trên văn bản 2025-2026, hướng tới 2030</a:t>
+              <a:t>Soạn theo văn bản mới nhất của Bộ GDĐT năm 2026</a:t>
             </a:r>
             <a:endParaRPr lang="en-US" sz="2600" dirty="0"/>
           </a:p>
@@ -6519,7 +6519,7 @@
                           <a:ea typeface="Arial" pitchFamily="34" charset="-122"/>
                           <a:cs typeface="Arial" pitchFamily="34" charset="-120"/>
                         </a:rPr>
-                        <a:t>Chiến lược quốc gia về AI đến 2030</a:t>
+                        <a:t>Khung năng lực số của giáo viên</a:t>
                       </a:r>
                       <a:endParaRPr lang="en-US" sz="1200" dirty="0">
                         <a:latin typeface="Arial" charset="0"/>
@@ -6563,7 +6563,7 @@
                           <a:ea typeface="Arial" pitchFamily="34" charset="-122"/>
                           <a:cs typeface="Arial" pitchFamily="34" charset="-120"/>
                         </a:rPr>
-                        <a:t>QĐ 1671/QĐ-TTg · 28/8/2026</a:t>
+                        <a:t>TT 18/2026/TT-BGDĐT · hiệu lực 12/5/2026</a:t>
                       </a:r>
                       <a:endParaRPr lang="en-US" sz="1050" dirty="0">
                         <a:latin typeface="Arial" charset="0"/>
@@ -6607,7 +6607,7 @@
                           <a:ea typeface="Arial" pitchFamily="34" charset="-122"/>
                           <a:cs typeface="Arial" pitchFamily="34" charset="-120"/>
                         </a:rPr>
-                        <a:t>AI là năng lực cốt lõi quốc gia</a:t>
+                        <a:t>AI là một miền năng lực riêng</a:t>
                       </a:r>
                       <a:endParaRPr lang="en-US" sz="1050" dirty="0">
                         <a:latin typeface="Arial" charset="0"/>
@@ -6653,7 +6653,7 @@
                           <a:ea typeface="Arial" pitchFamily="34" charset="-122"/>
                           <a:cs typeface="Arial" pitchFamily="34" charset="-120"/>
                         </a:rPr>
-                        <a:t>Phát triển nhân lực AI đến 2030</a:t>
+                        <a:t>Nhiệm vụ Mầm non 2026-2027</a:t>
                       </a:r>
                       <a:endParaRPr lang="en-US" sz="1200" dirty="0">
                         <a:latin typeface="Arial" charset="0"/>
@@ -6697,7 +6697,7 @@
                           <a:ea typeface="Arial" pitchFamily="34" charset="-122"/>
                           <a:cs typeface="Arial" pitchFamily="34" charset="-120"/>
                         </a:rPr>
-                        <a:t>QĐ 1528/QĐ-TTg · 2026</a:t>
+                        <a:t>CV 5385/BGDĐT-GDMN · 12/8/2026</a:t>
                       </a:r>
                       <a:endParaRPr lang="en-US" sz="1050" dirty="0">
                         <a:latin typeface="Arial" charset="0"/>
@@ -6741,7 +6741,7 @@
                           <a:ea typeface="Arial" pitchFamily="34" charset="-122"/>
                           <a:cs typeface="Arial" pitchFamily="34" charset="-120"/>
                         </a:rPr>
-                        <a:t>Nâng năng lực AI của người lao động</a:t>
+                        <a:t>Bồi dưỡng giáo viên ứng dụng AI</a:t>
                       </a:r>
                       <a:endParaRPr lang="en-US" sz="1050" dirty="0">
                         <a:latin typeface="Arial" charset="0"/>
@@ -6787,7 +6787,7 @@
                           <a:ea typeface="Arial" pitchFamily="34" charset="-122"/>
                           <a:cs typeface="Arial" pitchFamily="34" charset="-120"/>
                         </a:rPr>
-                        <a:t>Đột phá phát triển giáo dục</a:t>
+                        <a:t>Nhiệm vụ Phổ thông 2026-2027</a:t>
                       </a:r>
                       <a:endParaRPr lang="en-US" sz="1200" dirty="0">
                         <a:latin typeface="Arial" charset="0"/>
@@ -6831,7 +6831,7 @@
                           <a:ea typeface="Arial" pitchFamily="34" charset="-122"/>
                           <a:cs typeface="Arial" pitchFamily="34" charset="-120"/>
                         </a:rPr>
-                        <a:t>NQ 71-NQ/TW · 22/8/2025</a:t>
+                        <a:t>CV 5208/BGDĐT-GDPT · 07/8/2026</a:t>
                       </a:r>
                       <a:endParaRPr lang="en-US" sz="1050" dirty="0">
                         <a:latin typeface="Arial" charset="0"/>
@@ -6875,7 +6875,7 @@
                           <a:ea typeface="Arial" pitchFamily="34" charset="-122"/>
                           <a:cs typeface="Arial" pitchFamily="34" charset="-120"/>
                         </a:rPr>
-                        <a:t>Mục tiêu giáo dục đến 2030, 2045</a:t>
+                        <a:t>Học sinh dùng AI an toàn, trung thực</a:t>
                       </a:r>
                       <a:endParaRPr lang="en-US" sz="1050" dirty="0">
                         <a:latin typeface="Arial" charset="0"/>
@@ -6921,7 +6921,7 @@
                           <a:ea typeface="Arial" pitchFamily="34" charset="-122"/>
                           <a:cs typeface="Arial" pitchFamily="34" charset="-120"/>
                         </a:rPr>
-                        <a:t>Luật Trí tuệ nhân tạo</a:t>
+                        <a:t>Khung nội dung giáo dục AI</a:t>
                       </a:r>
                       <a:endParaRPr lang="en-US" sz="1200" dirty="0">
                         <a:latin typeface="Arial" charset="0"/>
@@ -6965,7 +6965,7 @@
                           <a:ea typeface="Arial" pitchFamily="34" charset="-122"/>
                           <a:cs typeface="Arial" pitchFamily="34" charset="-120"/>
                         </a:rPr>
-                        <a:t>134/2025/QH15 · hiệu lực 01/3/2026</a:t>
+                        <a:t>QĐ 2422/QĐ-BGDĐT · 18/8/2026</a:t>
                       </a:r>
                       <a:endParaRPr lang="en-US" sz="1050" dirty="0">
                         <a:latin typeface="Arial" charset="0"/>
@@ -7009,7 +7009,7 @@
                           <a:ea typeface="Arial" pitchFamily="34" charset="-122"/>
                           <a:cs typeface="Arial" pitchFamily="34" charset="-120"/>
                         </a:rPr>
-                        <a:t>Con người quyết định, gắn nhãn nội dung AI</a:t>
+                        <a:t>Giáo dục AI cho học sinh phổ thông</a:t>
                       </a:r>
                       <a:endParaRPr lang="en-US" sz="1050" dirty="0">
                         <a:latin typeface="Arial" charset="0"/>
@@ -7055,7 +7055,7 @@
                           <a:ea typeface="Arial" pitchFamily="34" charset="-122"/>
                           <a:cs typeface="Arial" pitchFamily="34" charset="-120"/>
                         </a:rPr>
-                        <a:t>Luật Bảo vệ dữ liệu cá nhân</a:t>
+                        <a:t>Triển khai giáo dục AI</a:t>
                       </a:r>
                       <a:endParaRPr lang="en-US" sz="1200" dirty="0">
                         <a:latin typeface="Arial" charset="0"/>
@@ -7099,7 +7099,7 @@
                           <a:ea typeface="Arial" pitchFamily="34" charset="-122"/>
                           <a:cs typeface="Arial" pitchFamily="34" charset="-120"/>
                         </a:rPr>
-                        <a:t>91/2025/QH15 · hiệu lực 01/1/2026</a:t>
+                        <a:t>CV 5588/BGDĐT-GDPT · 19/8/2026</a:t>
                       </a:r>
                       <a:endParaRPr lang="en-US" sz="1050" dirty="0">
                         <a:latin typeface="Arial" charset="0"/>
@@ -7143,7 +7143,7 @@
                           <a:ea typeface="Arial" pitchFamily="34" charset="-122"/>
                           <a:cs typeface="Arial" pitchFamily="34" charset="-120"/>
                         </a:rPr>
-                        <a:t>Không đưa dữ liệu học sinh vào AI</a:t>
+                        <a:t>12 tiết/lớp/năm học</a:t>
                       </a:r>
                       <a:endParaRPr lang="en-US" sz="1050" dirty="0">
                         <a:latin typeface="Arial" charset="0"/>
@@ -7189,7 +7189,7 @@
                           <a:ea typeface="Arial" pitchFamily="34" charset="-122"/>
                           <a:cs typeface="Arial" pitchFamily="34" charset="-120"/>
                         </a:rPr>
-                        <a:t>Khung năng lực số cho người học</a:t>
+                        <a:t>Nhiệm vụ trọng tâm năm học</a:t>
                       </a:r>
                       <a:endParaRPr lang="en-US" sz="1200" dirty="0">
                         <a:latin typeface="Arial" charset="0"/>
@@ -7233,7 +7233,7 @@
                           <a:ea typeface="Arial" pitchFamily="34" charset="-122"/>
                           <a:cs typeface="Arial" pitchFamily="34" charset="-120"/>
                         </a:rPr>
-                        <a:t>TT 02/2025/TT-BGDĐT</a:t>
+                        <a:t>Chỉ thị 31/CT-TTg · 05/8/2026</a:t>
                       </a:r>
                       <a:endParaRPr lang="en-US" sz="1050" dirty="0">
                         <a:latin typeface="Arial" charset="0"/>
@@ -7277,7 +7277,7 @@
                           <a:ea typeface="Arial" pitchFamily="34" charset="-122"/>
                           <a:cs typeface="Arial" pitchFamily="34" charset="-120"/>
                         </a:rPr>
-                        <a:t>Học sinh dùng AI an toàn, trung thực</a:t>
+                        <a:t>Ứng dụng AI có kiểm soát</a:t>
                       </a:r>
                       <a:endParaRPr lang="en-US" sz="1050" dirty="0">
                         <a:latin typeface="Arial" charset="0"/>
@@ -7323,7 +7323,7 @@
                           <a:ea typeface="Arial" pitchFamily="34" charset="-122"/>
                           <a:cs typeface="Arial" pitchFamily="34" charset="-120"/>
                         </a:rPr>
-                        <a:t>Hướng dẫn dùng AI dạy học</a:t>
+                        <a:t>Luật Trí tuệ nhân tạo · Bảo vệ dữ liệu</a:t>
                       </a:r>
                       <a:endParaRPr lang="en-US" sz="1200" dirty="0">
                         <a:latin typeface="Arial" charset="0"/>
@@ -7367,7 +7367,7 @@
                           <a:ea typeface="Arial" pitchFamily="34" charset="-122"/>
                           <a:cs typeface="Arial" pitchFamily="34" charset="-120"/>
                         </a:rPr>
-                        <a:t>CV 2250 · CV 5835 (2025)</a:t>
+                        <a:t>134/2025/QH15 · 91/2025/QH15</a:t>
                       </a:r>
                       <a:endParaRPr lang="en-US" sz="1050" dirty="0">
                         <a:latin typeface="Arial" charset="0"/>
@@ -7411,7 +7411,7 @@
                           <a:ea typeface="Arial" pitchFamily="34" charset="-122"/>
                           <a:cs typeface="Arial" pitchFamily="34" charset="-120"/>
                         </a:rPr>
-                        <a:t>Bồi dưỡng giáo viên ứng dụng AI</a:t>
+                        <a:t>Con người quyết định, bảo vệ dữ liệu</a:t>
                       </a:r>
                       <a:endParaRPr lang="en-US" sz="1050" dirty="0">
                         <a:latin typeface="Arial" charset="0"/>
@@ -7503,7 +7503,7 @@
                 <a:ea typeface="Arial" pitchFamily="34" charset="-122"/>
                 <a:cs typeface="Arial" pitchFamily="34" charset="-120"/>
               </a:rPr>
-              <a:t>Đầy đủ 17 văn bản: sách, trang 6</a:t>
+              <a:t>Đầy đủ 20 văn bản: sách, trang 6</a:t>
             </a:r>
             <a:endParaRPr lang="en-US" sz="1000" dirty="0"/>
           </a:p>
@@ -7625,7 +7625,7 @@
                 <a:ea typeface="Arial" pitchFamily="34" charset="-122"/>
                 <a:cs typeface="Arial" pitchFamily="34" charset="-120"/>
               </a:rPr>
-              <a:t>Đọc kỹ trong sách: Bài 1, trang 9</a:t>
+              <a:t>Đọc kỹ trong sách: Bài 1, trang 10</a:t>
             </a:r>
             <a:endParaRPr lang="en-US" sz="1000" dirty="0"/>
           </a:p>
@@ -7747,7 +7747,7 @@
                 <a:ea typeface="Arial" pitchFamily="34" charset="-122"/>
                 <a:cs typeface="Arial" pitchFamily="34" charset="-120"/>
               </a:rPr>
-              <a:t>Đọc kỹ trong sách: Bài 2, trang 10</a:t>
+              <a:t>Đọc kỹ trong sách: Bài 2, trang 11</a:t>
             </a:r>
             <a:endParaRPr lang="en-US" sz="1000" dirty="0"/>
           </a:p>
@@ -7869,7 +7869,7 @@
                 <a:ea typeface="Arial" pitchFamily="34" charset="-122"/>
                 <a:cs typeface="Arial" pitchFamily="34" charset="-120"/>
               </a:rPr>
-              <a:t>Đọc kỹ trong sách: Bài 3, trang 12</a:t>
+              <a:t>Đọc kỹ trong sách: Bài 3, trang 13</a:t>
             </a:r>
             <a:endParaRPr lang="en-US" sz="1000" dirty="0"/>
           </a:p>
@@ -8116,7 +8116,7 @@
                 <a:ea typeface="Arial" pitchFamily="34" charset="-122"/>
                 <a:cs typeface="Arial" pitchFamily="34" charset="-120"/>
               </a:rPr>
-              <a:t>Bài 4 đến Bài 10 · sách trang 15 đến 25</a:t>
+              <a:t>Bài 4 đến Bài 10 · sách trang 16 đến 26</a:t>
             </a:r>
             <a:endParaRPr lang="en-US" sz="1400" dirty="0"/>
           </a:p>
@@ -8238,7 +8238,7 @@
                 <a:ea typeface="Arial" pitchFamily="34" charset="-122"/>
                 <a:cs typeface="Arial" pitchFamily="34" charset="-120"/>
               </a:rPr>
-              <a:t>Đọc kỹ trong sách: Bài 4 (trang 15) đến Bài 7 (trang 19)</a:t>
+              <a:t>Đọc kỹ trong sách: Bài 4 (trang 16) đến Bài 7 (trang 20)</a:t>
             </a:r>
             <a:endParaRPr lang="en-US" sz="1000" dirty="0"/>
           </a:p>
@@ -8360,7 +8360,7 @@
                 <a:ea typeface="Arial" pitchFamily="34" charset="-122"/>
                 <a:cs typeface="Arial" pitchFamily="34" charset="-120"/>
               </a:rPr>
-              <a:t>Đọc kỹ trong sách: Bài 8, trang 21</a:t>
+              <a:t>Đọc kỹ trong sách: Bài 8, trang 22</a:t>
             </a:r>
             <a:endParaRPr lang="en-US" sz="1000" dirty="0"/>
           </a:p>

</xml_diff>

<commit_message>
Trình bày tệp 00, 01, 03 theo Nghị định 30/2020/NĐ-CP; bỏ dấu mũi tên
- Times New Roman, chữ đen, cỡ 13, lề 20/20/30/15 mm, căn đều hai lề
- Số trang giữa lề trên, không đánh số trang đầu
- Ngắt trang trước tiêu đề bài, không còn trang trống
- 195 tham chiếu trang và 32 tham chiếu slide kiểm tra lại, 0 sai

Co-Authored-By: Claude Opus 5.5 <noreply@anthropic.com>
Claude-Session: https://claude.ai/code/session_016W4H5FXW9gSiS33Aau8aSB
</commit_message>
<xml_diff>
--- a/BO-TAI-LIEU-GUI-KHACH/04-Slide-tap-huan.pptx
+++ b/BO-TAI-LIEU-GUI-KHACH/04-Slide-tap-huan.pptx
@@ -613,7 +613,7 @@
           <a:p>
             <a:r>
               <a:rPr lang="en-US" dirty="0"/>
-              <a:t>TPACK: điền đủ 3 dòng CK, PK, TK. Học viên mở tệp 01, Bài 10, trang 25.</a:t>
+              <a:t>TPACK: điền đủ 3 dòng CK, PK, TK. Học viên mở tệp 01, Bài 10, trang 27.</a:t>
             </a:r>
             <a:endParaRPr lang="en-US" dirty="0"/>
           </a:p>
@@ -789,7 +789,7 @@
           <a:p>
             <a:r>
               <a:rPr lang="en-US" dirty="0"/>
-              <a:t>Câu lệnh dài chia 4 ngăn có tiêu đề #. Học viên mở tệp 01, Bài 15, trang 32.</a:t>
+              <a:t>Câu lệnh dài chia 4 ngăn có tiêu đề #. Học viên mở tệp 01, Bài 15, trang 34.</a:t>
             </a:r>
             <a:endParaRPr lang="en-US" dirty="0"/>
           </a:p>
@@ -877,7 +877,7 @@
           <a:p>
             <a:r>
               <a:rPr lang="en-US" dirty="0"/>
-              <a:t>Dán nguyên văn định nghĩa 4 mức độ nhận thức vào câu lệnh. Học viên mở tệp 01, Bài 16, trang 34.</a:t>
+              <a:t>Dán nguyên văn định nghĩa 4 mức độ nhận thức vào câu lệnh. Học viên mở tệp 01, Bài 16, trang 36.</a:t>
             </a:r>
             <a:endParaRPr lang="en-US" dirty="0"/>
           </a:p>
@@ -965,7 +965,7 @@
           <a:p>
             <a:r>
               <a:rPr lang="en-US" dirty="0"/>
-              <a:t>AI kẻ bảng tiêu chí 4 mức, giáo viên duyệt. Học viên mở tệp 01, Bài 17, trang 36.</a:t>
+              <a:t>AI kẻ bảng tiêu chí 4 mức, giáo viên duyệt. Học viên mở tệp 01, Bài 17, trang 38.</a:t>
             </a:r>
             <a:endParaRPr lang="en-US" dirty="0"/>
           </a:p>
@@ -1141,7 +1141,7 @@
           <a:p>
             <a:r>
               <a:rPr lang="en-US" dirty="0"/>
-              <a:t>Chọn công cụ theo sản phẩm muốn làm. Học viên mở tệp 01, Phần 4, trang 40.</a:t>
+              <a:t>Chọn công cụ theo sản phẩm muốn làm. Học viên mở tệp 01, Phần 4, trang 42.</a:t>
             </a:r>
             <a:endParaRPr lang="en-US" dirty="0"/>
           </a:p>
@@ -1229,7 +1229,7 @@
           <a:p>
             <a:r>
               <a:rPr lang="en-US" dirty="0"/>
-              <a:t>Câu lệnh tạo ảnh: Nội dung + Phong cách. Học viên mở tệp 01, Bài 20, trang 41.</a:t>
+              <a:t>Câu lệnh tạo ảnh: Nội dung + Phong cách. Học viên mở tệp 01, Bài 20, trang 43.</a:t>
             </a:r>
             <a:endParaRPr lang="en-US" dirty="0"/>
           </a:p>
@@ -1405,7 +1405,7 @@
           <a:p>
             <a:r>
               <a:rPr lang="en-US" dirty="0"/>
-              <a:t>Deep Research: giao đề bài, duyệt kế hoạch, chờ báo cáo, tự mở từng link để kiểm. Học viên mở tệp 01, Bài 28, trang 56.</a:t>
+              <a:t>Deep Research: giao đề bài, duyệt kế hoạch, chờ báo cáo, tự mở từng link để kiểm. Học viên mở tệp 01, Bài 28, trang 58.</a:t>
             </a:r>
             <a:endParaRPr lang="en-US" dirty="0"/>
           </a:p>
@@ -1581,7 +1581,7 @@
           <a:p>
             <a:r>
               <a:rPr lang="en-US" dirty="0"/>
-              <a:t>Tạo trợ giảng ảo 4 bước. Câu quan trọng nhất: không đưa ra ngay đáp án. Học viên mở tệp 01, Bài 31, trang 60.</a:t>
+              <a:t>Tạo trợ giảng ảo 4 bước. Câu quan trọng nhất: không đưa ra ngay đáp án. Học viên mở tệp 01, Bài 31, trang 62.</a:t>
             </a:r>
             <a:endParaRPr lang="en-US" dirty="0"/>
           </a:p>
@@ -1669,7 +1669,7 @@
           <a:p>
             <a:r>
               <a:rPr lang="en-US" dirty="0"/>
-              <a:t>Khung năng lực AI cho giáo viên của UNESCO: 5 lĩnh vực, 3 cấp độ. Học viên mở tệp 01, Bài 34, trang 67.</a:t>
+              <a:t>Khung năng lực AI cho giáo viên của UNESCO: 5 lĩnh vực, 3 cấp độ. Học viên mở tệp 01, Bài 34, trang 69.</a:t>
             </a:r>
             <a:endParaRPr lang="en-US" dirty="0"/>
           </a:p>
@@ -1757,7 +1757,7 @@
           <a:p>
             <a:r>
               <a:rPr lang="en-US" dirty="0"/>
-              <a:t>Ba màu đèn trước khi dán thông tin vào AI. Học viên mở tệp 01, Bài 35, trang 69.</a:t>
+              <a:t>Ba màu đèn trước khi dán thông tin vào AI. Học viên mở tệp 01, Bài 35, trang 71.</a:t>
             </a:r>
             <a:endParaRPr lang="en-US" dirty="0"/>
           </a:p>
@@ -1845,7 +1845,7 @@
           <a:p>
             <a:r>
               <a:rPr lang="en-US" dirty="0"/>
-              <a:t>Gợi ý bắt đầu theo cấp học. Học viên mở tệp 01, Phụ lục 1, trang 72.</a:t>
+              <a:t>Gợi ý bắt đầu theo cấp học. Học viên mở tệp 01, Phụ lục 1, trang 74.</a:t>
             </a:r>
             <a:endParaRPr lang="en-US" dirty="0"/>
           </a:p>
@@ -2109,7 +2109,7 @@
           <a:p>
             <a:r>
               <a:rPr lang="en-US" dirty="0"/>
-              <a:t>Vòng làm việc Hỏi, Đọc, Sửa, Kiểm. Nhấn mạnh bước Kiểm. Học viên mở tệp 01, Bài 1, trang 10.</a:t>
+              <a:t>Vòng làm việc Hỏi, Đọc, Sửa, Kiểm. Nhấn mạnh bước Kiểm. Học viên mở tệp 01, Bài 1, trang 11.</a:t>
             </a:r>
             <a:endParaRPr lang="en-US" dirty="0"/>
           </a:p>
@@ -2197,7 +2197,7 @@
           <a:p>
             <a:r>
               <a:rPr lang="en-US" dirty="0"/>
-              <a:t>Sáu vị trí trên màn hình trò chuyện với AI. Cho học viên mở chatgpt.com và tìm đủ 6 vị trí. Học viên mở tệp 01, Bài 2, trang 11.</a:t>
+              <a:t>Sáu vị trí trên màn hình trò chuyện với AI. Cho học viên mở chatgpt.com và tìm đủ 6 vị trí. Học viên mở tệp 01, Bài 2, trang 12.</a:t>
             </a:r>
             <a:endParaRPr lang="en-US" dirty="0"/>
           </a:p>
@@ -2285,7 +2285,7 @@
           <a:p>
             <a:r>
               <a:rPr lang="en-US" dirty="0"/>
-              <a:t>Sáu mảnh ghép của câu lệnh tốt. Học viên mở tệp 01, Bài 3, trang 13.</a:t>
+              <a:t>Sáu mảnh ghép của câu lệnh tốt. Học viên mở tệp 01, Bài 3, trang 14.</a:t>
             </a:r>
             <a:endParaRPr lang="en-US" dirty="0"/>
           </a:p>
@@ -2461,7 +2461,7 @@
           <a:p>
             <a:r>
               <a:rPr lang="en-US" dirty="0"/>
-              <a:t>Bốn cách hỏi từ dễ đến đủ. Học viên thử lần lượt 4 câu lệnh trên cùng một bài dạy. Học viên mở tệp 01, Bài 4 (trang 16) đến Bài 7 (trang 20).</a:t>
+              <a:t>Bốn cách hỏi từ dễ đến đủ. Học viên thử lần lượt 4 câu lệnh trên cùng một bài dạy. Học viên mở tệp 01, Bài 4 (trang 17) đến Bài 7 (trang 22).</a:t>
             </a:r>
             <a:endParaRPr lang="en-US" dirty="0"/>
           </a:p>
@@ -2549,7 +2549,7 @@
           <a:p>
             <a:r>
               <a:rPr lang="en-US" dirty="0"/>
-              <a:t>Tự chấm câu lệnh theo 6 mảnh ghép, thiếu gì thêm nấy. Học viên mở tệp 01, Bài 8, trang 22.</a:t>
+              <a:t>Tự chấm câu lệnh theo 6 mảnh ghép, thiếu gì thêm nấy. Học viên mở tệp 01, Bài 8, trang 24.</a:t>
             </a:r>
             <a:endParaRPr lang="en-US" dirty="0"/>
           </a:p>
@@ -3260,7 +3260,7 @@
                 <a:ea typeface="Arial" pitchFamily="34" charset="-122"/>
                 <a:cs typeface="Arial" pitchFamily="34" charset="-120"/>
               </a:rPr>
-              <a:t>Đọc kỹ trong sách: Bài 10, trang 25</a:t>
+              <a:t>Đọc kỹ trong sách: Bài 10, trang 27</a:t>
             </a:r>
             <a:endParaRPr lang="en-US" sz="1000" dirty="0"/>
           </a:p>
@@ -3507,7 +3507,7 @@
                 <a:ea typeface="Arial" pitchFamily="34" charset="-122"/>
                 <a:cs typeface="Arial" pitchFamily="34" charset="-120"/>
               </a:rPr>
-              <a:t>Bài 11 đến Bài 19 · sách trang 28 đến 39</a:t>
+              <a:t>Bài 11 đến Bài 19 · sách trang 30 đến 41</a:t>
             </a:r>
             <a:endParaRPr lang="en-US" sz="1400" dirty="0"/>
           </a:p>
@@ -3629,7 +3629,7 @@
                 <a:ea typeface="Arial" pitchFamily="34" charset="-122"/>
                 <a:cs typeface="Arial" pitchFamily="34" charset="-120"/>
               </a:rPr>
-              <a:t>Đọc kỹ trong sách: Bài 15, trang 32</a:t>
+              <a:t>Đọc kỹ trong sách: Bài 15, trang 34</a:t>
             </a:r>
             <a:endParaRPr lang="en-US" sz="1000" dirty="0"/>
           </a:p>
@@ -3751,7 +3751,7 @@
                 <a:ea typeface="Arial" pitchFamily="34" charset="-122"/>
                 <a:cs typeface="Arial" pitchFamily="34" charset="-120"/>
               </a:rPr>
-              <a:t>Đọc kỹ trong sách: Bài 16, trang 34</a:t>
+              <a:t>Đọc kỹ trong sách: Bài 16, trang 36</a:t>
             </a:r>
             <a:endParaRPr lang="en-US" sz="1000" dirty="0"/>
           </a:p>
@@ -3873,7 +3873,7 @@
                 <a:ea typeface="Arial" pitchFamily="34" charset="-122"/>
                 <a:cs typeface="Arial" pitchFamily="34" charset="-120"/>
               </a:rPr>
-              <a:t>Đọc kỹ trong sách: Bài 17, trang 36</a:t>
+              <a:t>Đọc kỹ trong sách: Bài 17, trang 38</a:t>
             </a:r>
             <a:endParaRPr lang="en-US" sz="1000" dirty="0"/>
           </a:p>
@@ -4120,7 +4120,7 @@
                 <a:ea typeface="Arial" pitchFamily="34" charset="-122"/>
                 <a:cs typeface="Arial" pitchFamily="34" charset="-120"/>
               </a:rPr>
-              <a:t>Bài 20 đến Bài 27 · sách trang 41 đến 54</a:t>
+              <a:t>Bài 20 đến Bài 27 · sách trang 43 đến 56</a:t>
             </a:r>
             <a:endParaRPr lang="en-US" sz="1400" dirty="0"/>
           </a:p>
@@ -4242,7 +4242,7 @@
                 <a:ea typeface="Arial" pitchFamily="34" charset="-122"/>
                 <a:cs typeface="Arial" pitchFamily="34" charset="-120"/>
               </a:rPr>
-              <a:t>Đọc kỹ trong sách: Phần 4, trang 40</a:t>
+              <a:t>Đọc kỹ trong sách: Phần 4, trang 42</a:t>
             </a:r>
             <a:endParaRPr lang="en-US" sz="1000" dirty="0"/>
           </a:p>
@@ -4364,7 +4364,7 @@
                 <a:ea typeface="Arial" pitchFamily="34" charset="-122"/>
                 <a:cs typeface="Arial" pitchFamily="34" charset="-120"/>
               </a:rPr>
-              <a:t>Đọc kỹ trong sách: Bài 20, trang 41</a:t>
+              <a:t>Đọc kỹ trong sách: Bài 20, trang 43</a:t>
             </a:r>
             <a:endParaRPr lang="en-US" sz="1000" dirty="0"/>
           </a:p>
@@ -4611,7 +4611,7 @@
                 <a:ea typeface="Arial" pitchFamily="34" charset="-122"/>
                 <a:cs typeface="Arial" pitchFamily="34" charset="-120"/>
               </a:rPr>
-              <a:t>Bài 28 đến Bài 36 · sách trang 56 đến 70</a:t>
+              <a:t>Bài 28 đến Bài 36 · sách trang 58 đến 72</a:t>
             </a:r>
             <a:endParaRPr lang="en-US" sz="1400" dirty="0"/>
           </a:p>
@@ -4733,7 +4733,7 @@
                 <a:ea typeface="Arial" pitchFamily="34" charset="-122"/>
                 <a:cs typeface="Arial" pitchFamily="34" charset="-120"/>
               </a:rPr>
-              <a:t>Đọc kỹ trong sách: Bài 28, trang 56</a:t>
+              <a:t>Đọc kỹ trong sách: Bài 28, trang 58</a:t>
             </a:r>
             <a:endParaRPr lang="en-US" sz="1000" dirty="0"/>
           </a:p>
@@ -5007,7 +5007,7 @@
                 <a:ea typeface="Arial" pitchFamily="34" charset="-122"/>
                 <a:cs typeface="Arial" pitchFamily="34" charset="-120"/>
               </a:rPr>
-              <a:t>Sách: Phần 3, trang 27</a:t>
+              <a:t>Sách: Phần 3, trang 29</a:t>
             </a:r>
             <a:endParaRPr lang="en-US" sz="1000" dirty="0"/>
           </a:p>
@@ -5210,7 +5210,7 @@
                 <a:ea typeface="Arial" pitchFamily="34" charset="-122"/>
                 <a:cs typeface="Arial" pitchFamily="34" charset="-120"/>
               </a:rPr>
-              <a:t>Sách: Phần 3, trang 27</a:t>
+              <a:t>Sách: Phần 3, trang 29</a:t>
             </a:r>
             <a:endParaRPr lang="en-US" sz="1000" dirty="0"/>
           </a:p>
@@ -5413,7 +5413,7 @@
                 <a:ea typeface="Arial" pitchFamily="34" charset="-122"/>
                 <a:cs typeface="Arial" pitchFamily="34" charset="-120"/>
               </a:rPr>
-              <a:t>Sách: Phần 4, trang 40</a:t>
+              <a:t>Sách: Phần 4, trang 42</a:t>
             </a:r>
             <a:endParaRPr lang="en-US" sz="1000" dirty="0"/>
           </a:p>
@@ -5616,7 +5616,7 @@
                 <a:ea typeface="Arial" pitchFamily="34" charset="-122"/>
                 <a:cs typeface="Arial" pitchFamily="34" charset="-120"/>
               </a:rPr>
-              <a:t>Sách: Phần 5, trang 55</a:t>
+              <a:t>Sách: Phần 5, trang 57</a:t>
             </a:r>
             <a:endParaRPr lang="en-US" sz="1000" dirty="0"/>
           </a:p>
@@ -5738,7 +5738,7 @@
                 <a:ea typeface="Arial" pitchFamily="34" charset="-122"/>
                 <a:cs typeface="Arial" pitchFamily="34" charset="-120"/>
               </a:rPr>
-              <a:t>Đọc kỹ trong sách: Bài 31, trang 60</a:t>
+              <a:t>Đọc kỹ trong sách: Bài 31, trang 62</a:t>
             </a:r>
             <a:endParaRPr lang="en-US" sz="1000" dirty="0"/>
           </a:p>
@@ -5860,7 +5860,7 @@
                 <a:ea typeface="Arial" pitchFamily="34" charset="-122"/>
                 <a:cs typeface="Arial" pitchFamily="34" charset="-120"/>
               </a:rPr>
-              <a:t>Đọc kỹ trong sách: Bài 34, trang 67</a:t>
+              <a:t>Đọc kỹ trong sách: Bài 34, trang 69</a:t>
             </a:r>
             <a:endParaRPr lang="en-US" sz="1000" dirty="0"/>
           </a:p>
@@ -5982,7 +5982,7 @@
                 <a:ea typeface="Arial" pitchFamily="34" charset="-122"/>
                 <a:cs typeface="Arial" pitchFamily="34" charset="-120"/>
               </a:rPr>
-              <a:t>Đọc kỹ trong sách: Bài 35, trang 69</a:t>
+              <a:t>Đọc kỹ trong sách: Bài 35, trang 71</a:t>
             </a:r>
             <a:endParaRPr lang="en-US" sz="1000" dirty="0"/>
           </a:p>
@@ -6104,7 +6104,7 @@
                 <a:ea typeface="Arial" pitchFamily="34" charset="-122"/>
                 <a:cs typeface="Arial" pitchFamily="34" charset="-120"/>
               </a:rPr>
-              <a:t>Đọc kỹ trong sách: Phụ lục 1, trang 72</a:t>
+              <a:t>Đọc kỹ trong sách: Phụ lục 1, trang 74</a:t>
             </a:r>
             <a:endParaRPr lang="en-US" sz="1000" dirty="0"/>
           </a:p>
@@ -6280,7 +6280,7 @@
                 <a:ea typeface="Arial" pitchFamily="34" charset="-122"/>
                 <a:cs typeface="Arial" pitchFamily="34" charset="-120"/>
               </a:rPr>
-              <a:t>Làm theo sách: Bài 2, trang 11</a:t>
+              <a:t>Làm theo sách: Bài 2, trang 12</a:t>
             </a:r>
             <a:endParaRPr lang="en-US" sz="1500" dirty="0"/>
           </a:p>
@@ -7625,7 +7625,7 @@
                 <a:ea typeface="Arial" pitchFamily="34" charset="-122"/>
                 <a:cs typeface="Arial" pitchFamily="34" charset="-120"/>
               </a:rPr>
-              <a:t>Đọc kỹ trong sách: Bài 1, trang 10</a:t>
+              <a:t>Đọc kỹ trong sách: Bài 1, trang 11</a:t>
             </a:r>
             <a:endParaRPr lang="en-US" sz="1000" dirty="0"/>
           </a:p>
@@ -7747,7 +7747,7 @@
                 <a:ea typeface="Arial" pitchFamily="34" charset="-122"/>
                 <a:cs typeface="Arial" pitchFamily="34" charset="-120"/>
               </a:rPr>
-              <a:t>Đọc kỹ trong sách: Bài 2, trang 11</a:t>
+              <a:t>Đọc kỹ trong sách: Bài 2, trang 12</a:t>
             </a:r>
             <a:endParaRPr lang="en-US" sz="1000" dirty="0"/>
           </a:p>
@@ -7869,7 +7869,7 @@
                 <a:ea typeface="Arial" pitchFamily="34" charset="-122"/>
                 <a:cs typeface="Arial" pitchFamily="34" charset="-120"/>
               </a:rPr>
-              <a:t>Đọc kỹ trong sách: Bài 3, trang 13</a:t>
+              <a:t>Đọc kỹ trong sách: Bài 3, trang 14</a:t>
             </a:r>
             <a:endParaRPr lang="en-US" sz="1000" dirty="0"/>
           </a:p>
@@ -8116,7 +8116,7 @@
                 <a:ea typeface="Arial" pitchFamily="34" charset="-122"/>
                 <a:cs typeface="Arial" pitchFamily="34" charset="-120"/>
               </a:rPr>
-              <a:t>Bài 4 đến Bài 10 · sách trang 16 đến 26</a:t>
+              <a:t>Bài 4 đến Bài 10 · sách trang 17 đến 28</a:t>
             </a:r>
             <a:endParaRPr lang="en-US" sz="1400" dirty="0"/>
           </a:p>
@@ -8238,7 +8238,7 @@
                 <a:ea typeface="Arial" pitchFamily="34" charset="-122"/>
                 <a:cs typeface="Arial" pitchFamily="34" charset="-120"/>
               </a:rPr>
-              <a:t>Đọc kỹ trong sách: Bài 4 (trang 16) đến Bài 7 (trang 20)</a:t>
+              <a:t>Đọc kỹ trong sách: Bài 4 (trang 17) đến Bài 7 (trang 22)</a:t>
             </a:r>
             <a:endParaRPr lang="en-US" sz="1000" dirty="0"/>
           </a:p>
@@ -8360,7 +8360,7 @@
                 <a:ea typeface="Arial" pitchFamily="34" charset="-122"/>
                 <a:cs typeface="Arial" pitchFamily="34" charset="-120"/>
               </a:rPr>
-              <a:t>Đọc kỹ trong sách: Bài 8, trang 22</a:t>
+              <a:t>Đọc kỹ trong sách: Bài 8, trang 24</a:t>
             </a:r>
             <a:endParaRPr lang="en-US" sz="1000" dirty="0"/>
           </a:p>

</xml_diff>